<commit_message>
docs: update 24/7 permanent deployment link to https://lakshya749.github.io/vaulty/
</commit_message>
<xml_diff>
--- a/COLLEGE_SUBMISSION_PACKAGE/03_PRESENTATION_SLIDES_FOR_TOMORROW.pptx
+++ b/COLLEGE_SUBMISSION_PACKAGE/03_PRESENTATION_SLIDES_FOR_TOMORROW.pptx
@@ -4703,7 +4703,7 @@
                   <a:srgbClr val="FFFFFF"/>
                 </a:solidFill>
               </a:rPr>
-              <a:t>Live Edge: https://confidential-municipality-venice-activated.trycloudflare.com</a:t>
+              <a:t>Live Edge: https://lakshya749.github.io/vaulty/</a:t>
             </a:r>
           </a:p>
         </p:txBody>
@@ -4856,11 +4856,11 @@
               </a:defRPr>
             </a:pPr>
             <a:r>
-              <a:t>Live Deployment: https://confidential-municipality-venice-activated.trycloudflare.com</a:t>
+              <a:t>Live Deployment: https://lakshya749.github.io/vaulty/</a:t>
             </a:r>
             <a:br/>
             <a:r>
-              <a:t>GitHub: https://github.com/lakshyasingh/vaulty | Email: lakshyasingh.bcr24224@imsnoida.com</a:t>
+              <a:t>GitHub: https://github.com/Lakshya749/vaulty | Email: lakshyasingh.bcr24224@imsnoida.com</a:t>
             </a:r>
           </a:p>
         </p:txBody>

</xml_diff>